<commit_message>
Replace generic Industry Context with Toyota AU-specific challenges
The 4 cards now directly map to problems our solution solves:
- Demand Volatility: RAV4 -74%, 3-6mo waits, 200K target at risk
- Parts Forecasting Gap: No RIM, Excel-based, can't split real vs stock demand
- Hybrid Supply Crunch: 3x demand surge, Aisin/Denso bottlenecks
- Distribution Complexity: 275 dealers, 8 states, model transitions

Also updated agenda item and key insight bar for Toyota AU.

Sources: CarsGuide, Automotive Logistics, Toyota AU Pressroom

https://claude.ai/code/session_01L66CbiPYwgrL1ehkMHCqJy
</commit_message>
<xml_diff>
--- a/backend/generated_ppts/NDBS_SAP_Supply_Chain_AI_v2.0.pptx
+++ b/backend/generated_ppts/NDBS_SAP_Supply_Chain_AI_v2.0.pptx
@@ -39128,7 +39128,7 @@
                   <a:srgbClr val="FFFFFF"/>
                 </a:solidFill>
               </a:rPr>
-              <a:t>Industry Context — Automotive Trends</a:t>
+              <a:t>Toyota AU — Supply Chain Challenges</a:t>
             </a:r>
           </a:p>
         </p:txBody>
@@ -39162,7 +39162,7 @@
                   <a:srgbClr val="B8CFE8"/>
                 </a:solidFill>
               </a:rPr>
-              <a:t>Macro forces reshaping supply chains</a:t>
+              <a:t>Real pain points across 275 dealerships</a:t>
             </a:r>
           </a:p>
         </p:txBody>
@@ -41858,7 +41858,7 @@
                   <a:srgbClr val="FFFFFF"/>
                 </a:solidFill>
               </a:rPr>
-              <a:t>Industry Context — Automotive Supply Chain</a:t>
+              <a:t>Toyota Australia — Supply Chain Challenges</a:t>
             </a:r>
           </a:p>
         </p:txBody>
@@ -41892,7 +41892,7 @@
                   <a:srgbClr val="B8CFE8"/>
                 </a:solidFill>
               </a:rPr>
-              <a:t>Macro forces driving urgency for AI-powered supply chains</a:t>
+              <a:t>Real challenges across your 275 dealerships that AI can solve today</a:t>
             </a:r>
           </a:p>
         </p:txBody>
@@ -41992,7 +41992,7 @@
         <p:spPr>
           <a:xfrm>
             <a:off x="550000" y="1650000"/>
-            <a:ext cx="2400000" cy="450000"/>
+            <a:ext cx="2400000" cy="500000"/>
           </a:xfrm>
           <a:prstGeom prst="rect">
             <a:avLst/>
@@ -42012,7 +42012,7 @@
                   <a:srgbClr val="0078D4"/>
                 </a:solidFill>
               </a:rPr>
-              <a:t>Chip Shortage Aftermath</a:t>
+              <a:t>Demand Volatility</a:t>
             </a:r>
           </a:p>
         </p:txBody>
@@ -42025,8 +42025,8 @@
         </p:nvSpPr>
         <p:spPr>
           <a:xfrm>
-            <a:off x="550000" y="2200000"/>
-            <a:ext cx="2400000" cy="2300000"/>
+            <a:off x="550000" y="2250000"/>
+            <a:ext cx="2400000" cy="2250000"/>
           </a:xfrm>
           <a:prstGeom prst="rect">
             <a:avLst/>
@@ -42045,12 +42045,12 @@
               </a:spcAft>
             </a:pPr>
             <a:r>
-              <a:rPr sz="1000" b="0">
+              <a:rPr sz="1041" b="0">
                 <a:solidFill>
                   <a:srgbClr val="B8CFE8"/>
                 </a:solidFill>
               </a:rPr>
-              <a:t>Global semiconductor crisis exposed single-source dependencies.</a:t>
+              <a:t>RAV4 sales down 74% in early 2026</a:t>
             </a:r>
           </a:p>
           <a:p>
@@ -42060,12 +42060,87 @@
               </a:spcAft>
             </a:pPr>
             <a:r>
-              <a:rPr sz="1000" b="0">
+              <a:rPr sz="1333" b="0">
                 <a:solidFill>
                   <a:srgbClr val="B8CFE8"/>
                 </a:solidFill>
               </a:rPr>
-              <a:t>3-year recovery timeline. OEMs now demand multi-tier visibility.</a:t>
+              <a:t>due to model transition gaps.</a:t>
+            </a:r>
+          </a:p>
+          <a:p>
+            <a:pPr algn="l">
+              <a:spcAft>
+                <a:spcPts val="400"/>
+              </a:spcAft>
+            </a:pPr>
+            <a:r>
+              <a:rPr sz="1333" b="0">
+                <a:solidFill>
+                  <a:srgbClr val="B8CFE8"/>
+                </a:solidFill>
+              </a:rPr>
+              <a:t/>
+            </a:r>
+          </a:p>
+          <a:p>
+            <a:pPr algn="l">
+              <a:spcAft>
+                <a:spcPts val="400"/>
+              </a:spcAft>
+            </a:pPr>
+            <a:r>
+              <a:rPr sz="1333" b="0">
+                <a:solidFill>
+                  <a:srgbClr val="B8CFE8"/>
+                </a:solidFill>
+              </a:rPr>
+              <a:t>3–6 month wait times persist</a:t>
+            </a:r>
+          </a:p>
+          <a:p>
+            <a:pPr algn="l">
+              <a:spcAft>
+                <a:spcPts val="400"/>
+              </a:spcAft>
+            </a:pPr>
+            <a:r>
+              <a:rPr sz="1333" b="0">
+                <a:solidFill>
+                  <a:srgbClr val="B8CFE8"/>
+                </a:solidFill>
+              </a:rPr>
+              <a:t>across the range. 200K+ unit</a:t>
+            </a:r>
+          </a:p>
+          <a:p>
+            <a:pPr algn="l">
+              <a:spcAft>
+                <a:spcPts val="400"/>
+              </a:spcAft>
+            </a:pPr>
+            <a:r>
+              <a:rPr sz="1333" b="0">
+                <a:solidFill>
+                  <a:srgbClr val="B8CFE8"/>
+                </a:solidFill>
+              </a:rPr>
+              <a:t>target at risk without better</a:t>
+            </a:r>
+          </a:p>
+          <a:p>
+            <a:pPr algn="l">
+              <a:spcAft>
+                <a:spcPts val="400"/>
+              </a:spcAft>
+            </a:pPr>
+            <a:r>
+              <a:rPr sz="1333" b="0">
+                <a:solidFill>
+                  <a:srgbClr val="B8CFE8"/>
+                </a:solidFill>
+              </a:rPr>
+              <a:t>demand visibility.</a:t>
             </a:r>
           </a:p>
         </p:txBody>
@@ -42165,7 +42240,7 @@
         <p:spPr>
           <a:xfrm>
             <a:off x="3450000" y="1650000"/>
-            <a:ext cx="2400000" cy="450000"/>
+            <a:ext cx="2400000" cy="500000"/>
           </a:xfrm>
           <a:prstGeom prst="rect">
             <a:avLst/>
@@ -42185,7 +42260,8 @@
                   <a:srgbClr val="00B294"/>
                 </a:solidFill>
               </a:rPr>
-              <a:t>EV Transition</a:t>
+              <a:t>Parts Forecasting
+Gap</a:t>
             </a:r>
           </a:p>
         </p:txBody>
@@ -42198,8 +42274,8 @@
         </p:nvSpPr>
         <p:spPr>
           <a:xfrm>
-            <a:off x="3450000" y="2200000"/>
-            <a:ext cx="2400000" cy="2300000"/>
+            <a:off x="3450000" y="2250000"/>
+            <a:ext cx="2400000" cy="2250000"/>
           </a:xfrm>
           <a:prstGeom prst="rect">
             <a:avLst/>
@@ -42218,12 +42294,12 @@
               </a:spcAft>
             </a:pPr>
             <a:r>
-              <a:rPr sz="1000" b="0">
+              <a:rPr sz="1333" b="0">
                 <a:solidFill>
                   <a:srgbClr val="B8CFE8"/>
                 </a:solidFill>
               </a:rPr>
-              <a:t>Battery supply chains are 5× more complex than ICE.</a:t>
+              <a:t>No retail inventory management</a:t>
             </a:r>
           </a:p>
           <a:p>
@@ -42233,12 +42309,87 @@
               </a:spcAft>
             </a:pPr>
             <a:r>
-              <a:rPr sz="1000" b="0">
+              <a:rPr sz="1333" b="0">
                 <a:solidFill>
                   <a:srgbClr val="B8CFE8"/>
                 </a:solidFill>
               </a:rPr>
-              <a:t>New BOM structures require completely different planning models.</a:t>
+              <a:t>system across dealer network.</a:t>
+            </a:r>
+          </a:p>
+          <a:p>
+            <a:pPr algn="l">
+              <a:spcAft>
+                <a:spcPts val="400"/>
+              </a:spcAft>
+            </a:pPr>
+            <a:r>
+              <a:rPr sz="1333" b="0">
+                <a:solidFill>
+                  <a:srgbClr val="B8CFE8"/>
+                </a:solidFill>
+              </a:rPr>
+              <a:t/>
+            </a:r>
+          </a:p>
+          <a:p>
+            <a:pPr algn="l">
+              <a:spcAft>
+                <a:spcPts val="400"/>
+              </a:spcAft>
+            </a:pPr>
+            <a:r>
+              <a:rPr sz="1333" b="0">
+                <a:solidFill>
+                  <a:srgbClr val="B8CFE8"/>
+                </a:solidFill>
+              </a:rPr>
+              <a:t>Cannot distinguish real demand</a:t>
+            </a:r>
+          </a:p>
+          <a:p>
+            <a:pPr algn="l">
+              <a:spcAft>
+                <a:spcPts val="400"/>
+              </a:spcAft>
+            </a:pPr>
+            <a:r>
+              <a:rPr sz="1333" b="0">
+                <a:solidFill>
+                  <a:srgbClr val="B8CFE8"/>
+                </a:solidFill>
+              </a:rPr>
+              <a:t>from stock replenishment.</a:t>
+            </a:r>
+          </a:p>
+          <a:p>
+            <a:pPr algn="l">
+              <a:spcAft>
+                <a:spcPts val="400"/>
+              </a:spcAft>
+            </a:pPr>
+            <a:r>
+              <a:rPr sz="1333" b="0">
+                <a:solidFill>
+                  <a:srgbClr val="B8CFE8"/>
+                </a:solidFill>
+              </a:rPr>
+              <a:t>Parts forecasting still relies</a:t>
+            </a:r>
+          </a:p>
+          <a:p>
+            <a:pPr algn="l">
+              <a:spcAft>
+                <a:spcPts val="400"/>
+              </a:spcAft>
+            </a:pPr>
+            <a:r>
+              <a:rPr sz="1333" b="0">
+                <a:solidFill>
+                  <a:srgbClr val="B8CFE8"/>
+                </a:solidFill>
+              </a:rPr>
+              <a:t>on Excel and manual overrides.</a:t>
             </a:r>
           </a:p>
         </p:txBody>
@@ -42338,7 +42489,7 @@
         <p:spPr>
           <a:xfrm>
             <a:off x="6350000" y="1650000"/>
-            <a:ext cx="2400000" cy="450000"/>
+            <a:ext cx="2400000" cy="500000"/>
           </a:xfrm>
           <a:prstGeom prst="rect">
             <a:avLst/>
@@ -42358,7 +42509,8 @@
                   <a:srgbClr val="FFB900"/>
                 </a:solidFill>
               </a:rPr>
-              <a:t>Sustainability Mandates</a:t>
+              <a:t>Hybrid Supply
+Crunch</a:t>
             </a:r>
           </a:p>
         </p:txBody>
@@ -42371,8 +42523,8 @@
         </p:nvSpPr>
         <p:spPr>
           <a:xfrm>
-            <a:off x="6350000" y="2200000"/>
-            <a:ext cx="2400000" cy="2300000"/>
+            <a:off x="6350000" y="2250000"/>
+            <a:ext cx="2400000" cy="2250000"/>
           </a:xfrm>
           <a:prstGeom prst="rect">
             <a:avLst/>
@@ -42391,12 +42543,12 @@
               </a:spcAft>
             </a:pPr>
             <a:r>
-              <a:rPr sz="1000" b="0">
+              <a:rPr sz="1333" b="0">
                 <a:solidFill>
                   <a:srgbClr val="B8CFE8"/>
                 </a:solidFill>
               </a:rPr>
-              <a:t>EU CSRD &amp; CBAM regulations demand Scope 3 tracking.</a:t>
+              <a:t>Hybrid demand surged 3× in</a:t>
             </a:r>
           </a:p>
           <a:p>
@@ -42406,12 +42558,87 @@
               </a:spcAft>
             </a:pPr>
             <a:r>
-              <a:rPr sz="1000" b="0">
+              <a:rPr sz="1333" b="0">
                 <a:solidFill>
                   <a:srgbClr val="B8CFE8"/>
                 </a:solidFill>
               </a:rPr>
-              <a:t>Supply chain carbon footprint visibility is now mandatory.</a:t>
+              <a:t>5 years — outstripping supply.</a:t>
+            </a:r>
+          </a:p>
+          <a:p>
+            <a:pPr algn="l">
+              <a:spcAft>
+                <a:spcPts val="400"/>
+              </a:spcAft>
+            </a:pPr>
+            <a:r>
+              <a:rPr sz="1333" b="0">
+                <a:solidFill>
+                  <a:srgbClr val="B8CFE8"/>
+                </a:solidFill>
+              </a:rPr>
+              <a:t/>
+            </a:r>
+          </a:p>
+          <a:p>
+            <a:pPr algn="l">
+              <a:spcAft>
+                <a:spcPts val="400"/>
+              </a:spcAft>
+            </a:pPr>
+            <a:r>
+              <a:rPr sz="1333" b="0">
+                <a:solidFill>
+                  <a:srgbClr val="B8CFE8"/>
+                </a:solidFill>
+              </a:rPr>
+              <a:t>Aisin magnet &amp; Denso inverter</a:t>
+            </a:r>
+          </a:p>
+          <a:p>
+            <a:pPr algn="l">
+              <a:spcAft>
+                <a:spcPts val="400"/>
+              </a:spcAft>
+            </a:pPr>
+            <a:r>
+              <a:rPr sz="1333" b="0">
+                <a:solidFill>
+                  <a:srgbClr val="B8CFE8"/>
+                </a:solidFill>
+              </a:rPr>
+              <a:t>bottlenecks. All components</a:t>
+            </a:r>
+          </a:p>
+          <a:p>
+            <a:pPr algn="l">
+              <a:spcAft>
+                <a:spcPts val="400"/>
+              </a:spcAft>
+            </a:pPr>
+            <a:r>
+              <a:rPr sz="1333" b="0">
+                <a:solidFill>
+                  <a:srgbClr val="B8CFE8"/>
+                </a:solidFill>
+              </a:rPr>
+              <a:t>shipped from Japan — logistics</a:t>
+            </a:r>
+          </a:p>
+          <a:p>
+            <a:pPr algn="l">
+              <a:spcAft>
+                <a:spcPts val="400"/>
+              </a:spcAft>
+            </a:pPr>
+            <a:r>
+              <a:rPr sz="1333" b="0">
+                <a:solidFill>
+                  <a:srgbClr val="B8CFE8"/>
+                </a:solidFill>
+              </a:rPr>
+              <a:t>delays compound the problem.</a:t>
             </a:r>
           </a:p>
         </p:txBody>
@@ -42511,7 +42738,7 @@
         <p:spPr>
           <a:xfrm>
             <a:off x="9250000" y="1650000"/>
-            <a:ext cx="2400000" cy="450000"/>
+            <a:ext cx="2400000" cy="500000"/>
           </a:xfrm>
           <a:prstGeom prst="rect">
             <a:avLst/>
@@ -42531,7 +42758,8 @@
                   <a:srgbClr val="FF8C00"/>
                 </a:solidFill>
               </a:rPr>
-              <a:t>Nearshoring &amp; China+1</a:t>
+              <a:t>Distribution
+Complexity</a:t>
             </a:r>
           </a:p>
         </p:txBody>
@@ -42544,8 +42772,8 @@
         </p:nvSpPr>
         <p:spPr>
           <a:xfrm>
-            <a:off x="9250000" y="2200000"/>
-            <a:ext cx="2400000" cy="2300000"/>
+            <a:off x="9250000" y="2250000"/>
+            <a:ext cx="2400000" cy="2250000"/>
           </a:xfrm>
           <a:prstGeom prst="rect">
             <a:avLst/>
@@ -42564,12 +42792,12 @@
               </a:spcAft>
             </a:pPr>
             <a:r>
-              <a:rPr sz="1000" b="0">
+              <a:rPr sz="1333" b="0">
                 <a:solidFill>
                   <a:srgbClr val="B8CFE8"/>
                 </a:solidFill>
               </a:rPr>
-              <a:t>Manufacturers restructuring supplier base.</a:t>
+              <a:t>275 dealers across 8 states.</a:t>
             </a:r>
           </a:p>
           <a:p>
@@ -42579,12 +42807,87 @@
               </a:spcAft>
             </a:pPr>
             <a:r>
-              <a:rPr sz="1000" b="0">
+              <a:rPr sz="1333" b="0">
                 <a:solidFill>
                   <a:srgbClr val="B8CFE8"/>
                 </a:solidFill>
               </a:rPr>
-              <a:t>Dynamic network optimization required as geography shifts.</a:t>
+              <a:t>Vast geography from Darwin to</a:t>
+            </a:r>
+          </a:p>
+          <a:p>
+            <a:pPr algn="l">
+              <a:spcAft>
+                <a:spcPts val="400"/>
+              </a:spcAft>
+            </a:pPr>
+            <a:r>
+              <a:rPr sz="1333" b="0">
+                <a:solidFill>
+                  <a:srgbClr val="B8CFE8"/>
+                </a:solidFill>
+              </a:rPr>
+              <a:t>Melbourne adds transit time.</a:t>
+            </a:r>
+          </a:p>
+          <a:p>
+            <a:pPr algn="l">
+              <a:spcAft>
+                <a:spcPts val="400"/>
+              </a:spcAft>
+            </a:pPr>
+            <a:r>
+              <a:rPr sz="1333" b="0">
+                <a:solidFill>
+                  <a:srgbClr val="B8CFE8"/>
+                </a:solidFill>
+              </a:rPr>
+              <a:t/>
+            </a:r>
+          </a:p>
+          <a:p>
+            <a:pPr algn="l">
+              <a:spcAft>
+                <a:spcPts val="400"/>
+              </a:spcAft>
+            </a:pPr>
+            <a:r>
+              <a:rPr sz="1333" b="0">
+                <a:solidFill>
+                  <a:srgbClr val="B8CFE8"/>
+                </a:solidFill>
+              </a:rPr>
+              <a:t>Model transitions (Fortuner</a:t>
+            </a:r>
+          </a:p>
+          <a:p>
+            <a:pPr algn="l">
+              <a:spcAft>
+                <a:spcPts val="400"/>
+              </a:spcAft>
+            </a:pPr>
+            <a:r>
+              <a:rPr sz="1333" b="0">
+                <a:solidFill>
+                  <a:srgbClr val="B8CFE8"/>
+                </a:solidFill>
+              </a:rPr>
+              <a:t>exit, new-gen RAV4 &amp; HiLux)</a:t>
+            </a:r>
+          </a:p>
+          <a:p>
+            <a:pPr algn="l">
+              <a:spcAft>
+                <a:spcPts val="400"/>
+              </a:spcAft>
+            </a:pPr>
+            <a:r>
+              <a:rPr sz="1333" b="0">
+                <a:solidFill>
+                  <a:srgbClr val="B8CFE8"/>
+                </a:solidFill>
+              </a:rPr>
+              <a:t>need dynamic stock rebalancing.</a:t>
             </a:r>
           </a:p>
         </p:txBody>
@@ -42695,7 +42998,7 @@
                   <a:srgbClr val="E8F4FD"/>
                 </a:solidFill>
               </a:rPr>
-              <a:t>Toyota Australia runs SAP ECC6 with rich order, logistics and parts data — but lacks the AI layer to turn it into predictive, autonomous action. This is the gap NDBS fills.</a:t>
+              <a:t>Toyota AU's SAP ECC6 holds years of order, parts and logistics data — but no AI layer to predict, optimise and act autonomously. This is exactly what NDBS delivers.</a:t>
             </a:r>
           </a:p>
         </p:txBody>

</xml_diff>